<commit_message>
docs: update PPTX documentation slider details to match new flex side-by-side layout
</commit_message>
<xml_diff>
--- a/CRC_Project_Documentation_New.pptx
+++ b/CRC_Project_Documentation_New.pptx
@@ -4701,7 +4701,7 @@
               </a:defRPr>
             </a:pPr>
             <a:r>
-              <a:t>   利用 CSS 疊層與 JS 拖曳事件，實現滑動拉桿時「威權校園」覆蓋底層「人權校園」的即時剪裁視覺特效。</a:t>
+              <a:t>   雙欄並排，左是傳統、右是實施後。拉至左邊不被右干擾，拉至右邊不被左干擾，文字自然換行不切斷。</a:t>
             </a:r>
           </a:p>
           <a:p>
@@ -4865,7 +4865,7 @@
               </a:defRPr>
             </a:pPr>
             <a:r>
-              <a:t>// AI 設計的拖拉滑動百分比計算</a:t>
+              <a:t>// AI 設計的雙欄並排拖拉百分比計算</a:t>
             </a:r>
           </a:p>
           <a:p>
@@ -4923,13 +4923,13 @@
               </a:spcAft>
               <a:defRPr sz="1000">
                 <a:solidFill>
-                  <a:srgbClr val="94A3B8"/>
+                  <a:srgbClr val="E2E8F0"/>
                 </a:solidFill>
                 <a:latin typeface="Consolas"/>
               </a:defRPr>
             </a:pPr>
             <a:r>
-              <a:t>  // 限制極限，避免把手拉出框外</a:t>
+              <a:t>  percent = Math.max(3, Math.min(97, percent));</a:t>
             </a:r>
           </a:p>
           <a:p>
@@ -4945,7 +4945,7 @@
               </a:defRPr>
             </a:pPr>
             <a:r>
-              <a:t>  percent = Math.max(3, Math.min(97, percent));</a:t>
+              <a:t>  handle.style.left = `${percent}%`;</a:t>
             </a:r>
           </a:p>
           <a:p>
@@ -4955,13 +4955,13 @@
               </a:spcAft>
               <a:defRPr sz="1000">
                 <a:solidFill>
-                  <a:srgbClr val="E2E8F0"/>
+                  <a:srgbClr val="C084FC"/>
                 </a:solidFill>
                 <a:latin typeface="Consolas"/>
               </a:defRPr>
             </a:pPr>
             <a:r>
-              <a:t>  handle.style.left = `${percent}%`;</a:t>
+              <a:t>  beforePanel.style.width = `${percent}%`;  // 傳統威權寬度</a:t>
             </a:r>
           </a:p>
           <a:p>
@@ -4977,7 +4977,7 @@
               </a:defRPr>
             </a:pPr>
             <a:r>
-              <a:t>  beforePanel.style.width = `${percent}%`; // 遮罩寬度</a:t>
+              <a:t>  afterPanel.style.width = `${100 - percent}%`; // 實施後寬度</a:t>
             </a:r>
           </a:p>
           <a:p>

</xml_diff>